<commit_message>
feat: harden CP3 ship path for public judging
Add session/rate-limit guards, buyer funding alert, verifier smoke test, CI, deploy docs, and updated deck/README for Encode final submission.

Co-authored-by: Cursor <cursoragent@cursor.com>
</commit_message>
<xml_diff>
--- a/gravai-deck.pptx
+++ b/gravai-deck.pptx
@@ -15,9 +15,10 @@
     <p:sldId id="263" r:id="rId9"/>
     <p:sldId id="264" r:id="rId10"/>
     <p:sldId id="265" r:id="rId11"/>
+    <p:sldId id="266" r:id="rId12"/>
   </p:sldIdLst>
   <p:notesMasterIdLst>
-    <p:notesMasterId r:id="rId12"/>
+    <p:notesMasterId r:id="rId13"/>
   </p:notesMasterIdLst>
   <p:sldSz cx="12188952" cy="6858000"/>
   <p:notesSz cx="6858000" cy="12188952"/>
@@ -623,6 +624,94 @@
             <a:fld id="{F7021451-1387-4CA6-816F-3879F97B5CBC}" type="slidenum">
               <a:rPr lang="en-US"/>
               <a:t>10</a:t>
+            </a:fld>
+            <a:endParaRPr lang="en-US"/>
+          </a:p>
+        </p:txBody>
+      </p:sp>
+    </p:spTree>
+    <p:extLst>
+      <p:ext uri="{BB962C8B-B14F-4D97-AF65-F5344CB8AC3E}">
+        <p14:creationId xmlns:p14="http://schemas.microsoft.com/office/powerpoint/2010/main" val="1024086991"/>
+      </p:ext>
+    </p:extLst>
+  </p:cSld>
+  <p:clrMapOvr>
+    <a:masterClrMapping/>
+  </p:clrMapOvr>
+</p:notes>
+</file>
+
+<file path=ppt/notesSlides/notesSlide11.xml><?xml version="1.0" encoding="utf-8"?>
+<p:notes xmlns:a="http://schemas.openxmlformats.org/drawingml/2006/main" xmlns:r="http://schemas.openxmlformats.org/officeDocument/2006/relationships" xmlns:p="http://schemas.openxmlformats.org/presentationml/2006/main">
+  <p:cSld>
+    <p:spTree>
+      <p:nvGrpSpPr>
+        <p:cNvPr id="1" name=""/>
+        <p:cNvGrpSpPr/>
+        <p:nvPr/>
+      </p:nvGrpSpPr>
+      <p:grpSpPr>
+        <a:xfrm>
+          <a:off x="0" y="0"/>
+          <a:ext cx="0" cy="0"/>
+          <a:chOff x="0" y="0"/>
+          <a:chExt cx="0" cy="0"/>
+        </a:xfrm>
+      </p:grpSpPr>
+      <p:sp>
+        <p:nvSpPr>
+          <p:cNvPr id="2" name="Slide Image Placeholder 1"/>
+          <p:cNvSpPr>
+            <a:spLocks noGrp="1" noRot="1" noChangeAspect="1"/>
+          </p:cNvSpPr>
+          <p:nvPr>
+            <p:ph type="sldImg"/>
+          </p:nvPr>
+        </p:nvSpPr>
+        <p:spPr/>
+      </p:sp>
+      <p:sp>
+        <p:nvSpPr>
+          <p:cNvPr id="3" name="Notes Placeholder 2"/>
+          <p:cNvSpPr>
+            <a:spLocks noGrp="1"/>
+          </p:cNvSpPr>
+          <p:nvPr>
+            <p:ph type="body" idx="1"/>
+          </p:nvPr>
+        </p:nvSpPr>
+        <p:spPr/>
+        <p:txBody>
+          <a:bodyPr/>
+          <a:lstStyle/>
+          <a:p>
+            <a:r>
+              <a:rPr lang="en-US" dirty="0"/>
+              <a:t/>
+            </a:r>
+            <a:endParaRPr lang="en-US" dirty="0"/>
+          </a:p>
+        </p:txBody>
+      </p:sp>
+      <p:sp>
+        <p:nvSpPr>
+          <p:cNvPr id="4" name="Slide Number Placeholder 3"/>
+          <p:cNvSpPr>
+            <a:spLocks noGrp="1"/>
+          </p:cNvSpPr>
+          <p:nvPr>
+            <p:ph type="sldNum" sz="quarter" idx="10"/>
+          </p:nvPr>
+        </p:nvSpPr>
+        <p:spPr/>
+        <p:txBody>
+          <a:bodyPr/>
+          <a:lstStyle/>
+          <a:p>
+            <a:fld id="{F7021451-1387-4CA6-816F-3879F97B5CBC}" type="slidenum">
+              <a:rPr lang="en-US"/>
+              <a:t>11</a:t>
             </a:fld>
             <a:endParaRPr lang="en-US"/>
           </a:p>
@@ -1909,14 +1998,92 @@
       </p:grpSpPr>
       <p:sp>
         <p:nvSpPr>
-          <p:cNvPr id="2" name="Shape 0"/>
-          <p:cNvSpPr/>
-          <p:nvPr/>
-        </p:nvSpPr>
-        <p:spPr>
-          <a:xfrm>
-            <a:off x="0" y="0"/>
-            <a:ext cx="109728" cy="6858000"/>
+          <p:cNvPr id="2" name="Text 0"/>
+          <p:cNvSpPr/>
+          <p:nvPr/>
+        </p:nvSpPr>
+        <p:spPr>
+          <a:xfrm>
+            <a:off x="548640" y="502920"/>
+            <a:ext cx="7315200" cy="292608"/>
+          </a:xfrm>
+          <a:prstGeom prst="rect">
+            <a:avLst/>
+          </a:prstGeom>
+          <a:noFill/>
+          <a:ln/>
+        </p:spPr>
+        <p:txBody>
+          <a:bodyPr wrap="square" rtlCol="0" anchor="ctr"/>
+          <a:lstStyle/>
+          <a:p>
+            <a:pPr indent="0" marL="0">
+              <a:buNone/>
+            </a:pPr>
+            <a:r>
+              <a:rPr lang="en-US" sz="1000" b="1" spc="300" kern="0" dirty="0">
+                <a:solidFill>
+                  <a:srgbClr val="34D399"/>
+                </a:solidFill>
+                <a:latin typeface="Segoe UI" pitchFamily="34" charset="0"/>
+                <a:ea typeface="Segoe UI" pitchFamily="34" charset="-122"/>
+                <a:cs typeface="Segoe UI" pitchFamily="34" charset="-120"/>
+              </a:rPr>
+              <a:t>FINAL SUBMISSION LINKS</a:t>
+            </a:r>
+            <a:endParaRPr lang="en-US" sz="1000" dirty="0"/>
+          </a:p>
+        </p:txBody>
+      </p:sp>
+      <p:sp>
+        <p:nvSpPr>
+          <p:cNvPr id="3" name="Text 1"/>
+          <p:cNvSpPr/>
+          <p:nvPr/>
+        </p:nvSpPr>
+        <p:spPr>
+          <a:xfrm>
+            <a:off x="502920" y="868680"/>
+            <a:ext cx="11155680" cy="731520"/>
+          </a:xfrm>
+          <a:prstGeom prst="rect">
+            <a:avLst/>
+          </a:prstGeom>
+          <a:noFill/>
+          <a:ln/>
+        </p:spPr>
+        <p:txBody>
+          <a:bodyPr wrap="square" rtlCol="0" anchor="ctr"/>
+          <a:lstStyle/>
+          <a:p>
+            <a:pPr indent="0" marL="0">
+              <a:buNone/>
+            </a:pPr>
+            <a:r>
+              <a:rPr lang="en-US" sz="3000" b="1" dirty="0">
+                <a:solidFill>
+                  <a:srgbClr val="E7ECEA"/>
+                </a:solidFill>
+                <a:latin typeface="Segoe UI" pitchFamily="34" charset="0"/>
+                <a:ea typeface="Segoe UI" pitchFamily="34" charset="-122"/>
+                <a:cs typeface="Segoe UI" pitchFamily="34" charset="-120"/>
+              </a:rPr>
+              <a:t>Everything a judge needs — public, no private logins.</a:t>
+            </a:r>
+            <a:endParaRPr lang="en-US" sz="3000" dirty="0"/>
+          </a:p>
+        </p:txBody>
+      </p:sp>
+      <p:sp>
+        <p:nvSpPr>
+          <p:cNvPr id="4" name="Shape 2"/>
+          <p:cNvSpPr/>
+          <p:nvPr/>
+        </p:nvSpPr>
+        <p:spPr>
+          <a:xfrm>
+            <a:off x="548640" y="1920240"/>
+            <a:ext cx="64008" cy="777240"/>
           </a:xfrm>
           <a:prstGeom prst="rect">
             <a:avLst/>
@@ -1929,6 +2096,469 @@
       </p:sp>
       <p:sp>
         <p:nvSpPr>
+          <p:cNvPr id="5" name="Text 3"/>
+          <p:cNvSpPr/>
+          <p:nvPr/>
+        </p:nvSpPr>
+        <p:spPr>
+          <a:xfrm>
+            <a:off x="777240" y="1920240"/>
+            <a:ext cx="2194560" cy="777240"/>
+          </a:xfrm>
+          <a:prstGeom prst="rect">
+            <a:avLst/>
+          </a:prstGeom>
+          <a:noFill/>
+          <a:ln/>
+        </p:spPr>
+        <p:txBody>
+          <a:bodyPr wrap="square" rtlCol="0" anchor="ctr"/>
+          <a:lstStyle/>
+          <a:p>
+            <a:pPr indent="0" marL="0">
+              <a:buNone/>
+            </a:pPr>
+            <a:r>
+              <a:rPr lang="en-US" sz="1600" b="1" dirty="0">
+                <a:solidFill>
+                  <a:srgbClr val="E7ECEA"/>
+                </a:solidFill>
+                <a:latin typeface="Segoe UI" pitchFamily="34" charset="0"/>
+                <a:ea typeface="Segoe UI" pitchFamily="34" charset="-122"/>
+                <a:cs typeface="Segoe UI" pitchFamily="34" charset="-120"/>
+              </a:rPr>
+              <a:t>Repo</a:t>
+            </a:r>
+            <a:endParaRPr lang="en-US" sz="1600" dirty="0"/>
+          </a:p>
+        </p:txBody>
+      </p:sp>
+      <p:sp>
+        <p:nvSpPr>
+          <p:cNvPr id="6" name="Text 4"/>
+          <p:cNvSpPr/>
+          <p:nvPr/>
+        </p:nvSpPr>
+        <p:spPr>
+          <a:xfrm>
+            <a:off x="3108960" y="1920240"/>
+            <a:ext cx="8503920" cy="777240"/>
+          </a:xfrm>
+          <a:prstGeom prst="rect">
+            <a:avLst/>
+          </a:prstGeom>
+          <a:noFill/>
+          <a:ln/>
+        </p:spPr>
+        <p:txBody>
+          <a:bodyPr wrap="square" rtlCol="0" anchor="ctr"/>
+          <a:lstStyle/>
+          <a:p>
+            <a:pPr indent="0" marL="0">
+              <a:buNone/>
+            </a:pPr>
+            <a:r>
+              <a:rPr lang="en-US" sz="1400" dirty="0">
+                <a:solidFill>
+                  <a:srgbClr val="8BA39B"/>
+                </a:solidFill>
+                <a:latin typeface="Segoe UI" pitchFamily="34" charset="0"/>
+                <a:ea typeface="Segoe UI" pitchFamily="34" charset="-122"/>
+                <a:cs typeface="Segoe UI" pitchFamily="34" charset="-120"/>
+              </a:rPr>
+              <a:t>https://github.com/tetheusz/gravai</a:t>
+            </a:r>
+            <a:endParaRPr lang="en-US" sz="1400" dirty="0"/>
+          </a:p>
+        </p:txBody>
+      </p:sp>
+      <p:sp>
+        <p:nvSpPr>
+          <p:cNvPr id="7" name="Shape 5"/>
+          <p:cNvSpPr/>
+          <p:nvPr/>
+        </p:nvSpPr>
+        <p:spPr>
+          <a:xfrm>
+            <a:off x="548640" y="2880360"/>
+            <a:ext cx="64008" cy="777240"/>
+          </a:xfrm>
+          <a:prstGeom prst="rect">
+            <a:avLst/>
+          </a:prstGeom>
+          <a:solidFill>
+            <a:srgbClr val="34D399"/>
+          </a:solidFill>
+          <a:ln/>
+        </p:spPr>
+      </p:sp>
+      <p:sp>
+        <p:nvSpPr>
+          <p:cNvPr id="8" name="Text 6"/>
+          <p:cNvSpPr/>
+          <p:nvPr/>
+        </p:nvSpPr>
+        <p:spPr>
+          <a:xfrm>
+            <a:off x="777240" y="2880360"/>
+            <a:ext cx="2194560" cy="777240"/>
+          </a:xfrm>
+          <a:prstGeom prst="rect">
+            <a:avLst/>
+          </a:prstGeom>
+          <a:noFill/>
+          <a:ln/>
+        </p:spPr>
+        <p:txBody>
+          <a:bodyPr wrap="square" rtlCol="0" anchor="ctr"/>
+          <a:lstStyle/>
+          <a:p>
+            <a:pPr indent="0" marL="0">
+              <a:buNone/>
+            </a:pPr>
+            <a:r>
+              <a:rPr lang="en-US" sz="1600" b="1" dirty="0">
+                <a:solidFill>
+                  <a:srgbClr val="E7ECEA"/>
+                </a:solidFill>
+                <a:latin typeface="Segoe UI" pitchFamily="34" charset="0"/>
+                <a:ea typeface="Segoe UI" pitchFamily="34" charset="-122"/>
+                <a:cs typeface="Segoe UI" pitchFamily="34" charset="-120"/>
+              </a:rPr>
+              <a:t>Live app</a:t>
+            </a:r>
+            <a:endParaRPr lang="en-US" sz="1600" dirty="0"/>
+          </a:p>
+        </p:txBody>
+      </p:sp>
+      <p:sp>
+        <p:nvSpPr>
+          <p:cNvPr id="9" name="Text 7"/>
+          <p:cNvSpPr/>
+          <p:nvPr/>
+        </p:nvSpPr>
+        <p:spPr>
+          <a:xfrm>
+            <a:off x="3108960" y="2880360"/>
+            <a:ext cx="8503920" cy="777240"/>
+          </a:xfrm>
+          <a:prstGeom prst="rect">
+            <a:avLst/>
+          </a:prstGeom>
+          <a:noFill/>
+          <a:ln/>
+        </p:spPr>
+        <p:txBody>
+          <a:bodyPr wrap="square" rtlCol="0" anchor="ctr"/>
+          <a:lstStyle/>
+          <a:p>
+            <a:pPr indent="0" marL="0">
+              <a:buNone/>
+            </a:pPr>
+            <a:r>
+              <a:rPr lang="en-US" sz="1400" dirty="0">
+                <a:solidFill>
+                  <a:srgbClr val="8BA39B"/>
+                </a:solidFill>
+                <a:latin typeface="Segoe UI" pitchFamily="34" charset="0"/>
+                <a:ea typeface="Segoe UI" pitchFamily="34" charset="-122"/>
+                <a:cs typeface="Segoe UI" pitchFamily="34" charset="-120"/>
+              </a:rPr>
+              <a:t>Deploy on Vercel → paste production URL in Encode + README</a:t>
+            </a:r>
+            <a:endParaRPr lang="en-US" sz="1400" dirty="0"/>
+          </a:p>
+        </p:txBody>
+      </p:sp>
+      <p:sp>
+        <p:nvSpPr>
+          <p:cNvPr id="10" name="Shape 8"/>
+          <p:cNvSpPr/>
+          <p:nvPr/>
+        </p:nvSpPr>
+        <p:spPr>
+          <a:xfrm>
+            <a:off x="548640" y="3840480"/>
+            <a:ext cx="64008" cy="777240"/>
+          </a:xfrm>
+          <a:prstGeom prst="rect">
+            <a:avLst/>
+          </a:prstGeom>
+          <a:solidFill>
+            <a:srgbClr val="34D399"/>
+          </a:solidFill>
+          <a:ln/>
+        </p:spPr>
+      </p:sp>
+      <p:sp>
+        <p:nvSpPr>
+          <p:cNvPr id="11" name="Text 9"/>
+          <p:cNvSpPr/>
+          <p:nvPr/>
+        </p:nvSpPr>
+        <p:spPr>
+          <a:xfrm>
+            <a:off x="777240" y="3840480"/>
+            <a:ext cx="2194560" cy="777240"/>
+          </a:xfrm>
+          <a:prstGeom prst="rect">
+            <a:avLst/>
+          </a:prstGeom>
+          <a:noFill/>
+          <a:ln/>
+        </p:spPr>
+        <p:txBody>
+          <a:bodyPr wrap="square" rtlCol="0" anchor="ctr"/>
+          <a:lstStyle/>
+          <a:p>
+            <a:pPr indent="0" marL="0">
+              <a:buNone/>
+            </a:pPr>
+            <a:r>
+              <a:rPr lang="en-US" sz="1600" b="1" dirty="0">
+                <a:solidFill>
+                  <a:srgbClr val="E7ECEA"/>
+                </a:solidFill>
+                <a:latin typeface="Segoe UI" pitchFamily="34" charset="0"/>
+                <a:ea typeface="Segoe UI" pitchFamily="34" charset="-122"/>
+                <a:cs typeface="Segoe UI" pitchFamily="34" charset="-120"/>
+              </a:rPr>
+              <a:t>Deck</a:t>
+            </a:r>
+            <a:endParaRPr lang="en-US" sz="1600" dirty="0"/>
+          </a:p>
+        </p:txBody>
+      </p:sp>
+      <p:sp>
+        <p:nvSpPr>
+          <p:cNvPr id="12" name="Text 10"/>
+          <p:cNvSpPr/>
+          <p:nvPr/>
+        </p:nvSpPr>
+        <p:spPr>
+          <a:xfrm>
+            <a:off x="3108960" y="3840480"/>
+            <a:ext cx="8503920" cy="777240"/>
+          </a:xfrm>
+          <a:prstGeom prst="rect">
+            <a:avLst/>
+          </a:prstGeom>
+          <a:noFill/>
+          <a:ln/>
+        </p:spPr>
+        <p:txBody>
+          <a:bodyPr wrap="square" rtlCol="0" anchor="ctr"/>
+          <a:lstStyle/>
+          <a:p>
+            <a:pPr indent="0" marL="0">
+              <a:buNone/>
+            </a:pPr>
+            <a:r>
+              <a:rPr lang="en-US" sz="1400" dirty="0">
+                <a:solidFill>
+                  <a:srgbClr val="8BA39B"/>
+                </a:solidFill>
+                <a:latin typeface="Segoe UI" pitchFamily="34" charset="0"/>
+                <a:ea typeface="Segoe UI" pitchFamily="34" charset="-122"/>
+                <a:cs typeface="Segoe UI" pitchFamily="34" charset="-120"/>
+              </a:rPr>
+              <a:t>Upload gravai-deck.pptx to Google Slides · anyone with the link</a:t>
+            </a:r>
+            <a:endParaRPr lang="en-US" sz="1400" dirty="0"/>
+          </a:p>
+        </p:txBody>
+      </p:sp>
+      <p:sp>
+        <p:nvSpPr>
+          <p:cNvPr id="13" name="Shape 11"/>
+          <p:cNvSpPr/>
+          <p:nvPr/>
+        </p:nvSpPr>
+        <p:spPr>
+          <a:xfrm>
+            <a:off x="548640" y="4800600"/>
+            <a:ext cx="64008" cy="777240"/>
+          </a:xfrm>
+          <a:prstGeom prst="rect">
+            <a:avLst/>
+          </a:prstGeom>
+          <a:solidFill>
+            <a:srgbClr val="34D399"/>
+          </a:solidFill>
+          <a:ln/>
+        </p:spPr>
+      </p:sp>
+      <p:sp>
+        <p:nvSpPr>
+          <p:cNvPr id="14" name="Text 12"/>
+          <p:cNvSpPr/>
+          <p:nvPr/>
+        </p:nvSpPr>
+        <p:spPr>
+          <a:xfrm>
+            <a:off x="777240" y="4800600"/>
+            <a:ext cx="2194560" cy="777240"/>
+          </a:xfrm>
+          <a:prstGeom prst="rect">
+            <a:avLst/>
+          </a:prstGeom>
+          <a:noFill/>
+          <a:ln/>
+        </p:spPr>
+        <p:txBody>
+          <a:bodyPr wrap="square" rtlCol="0" anchor="ctr"/>
+          <a:lstStyle/>
+          <a:p>
+            <a:pPr indent="0" marL="0">
+              <a:buNone/>
+            </a:pPr>
+            <a:r>
+              <a:rPr lang="en-US" sz="1600" b="1" dirty="0">
+                <a:solidFill>
+                  <a:srgbClr val="E7ECEA"/>
+                </a:solidFill>
+                <a:latin typeface="Segoe UI" pitchFamily="34" charset="0"/>
+                <a:ea typeface="Segoe UI" pitchFamily="34" charset="-122"/>
+                <a:cs typeface="Segoe UI" pitchFamily="34" charset="-120"/>
+              </a:rPr>
+              <a:t>Video</a:t>
+            </a:r>
+            <a:endParaRPr lang="en-US" sz="1600" dirty="0"/>
+          </a:p>
+        </p:txBody>
+      </p:sp>
+      <p:sp>
+        <p:nvSpPr>
+          <p:cNvPr id="15" name="Text 13"/>
+          <p:cNvSpPr/>
+          <p:nvPr/>
+        </p:nvSpPr>
+        <p:spPr>
+          <a:xfrm>
+            <a:off x="3108960" y="4800600"/>
+            <a:ext cx="8503920" cy="777240"/>
+          </a:xfrm>
+          <a:prstGeom prst="rect">
+            <a:avLst/>
+          </a:prstGeom>
+          <a:noFill/>
+          <a:ln/>
+        </p:spPr>
+        <p:txBody>
+          <a:bodyPr wrap="square" rtlCol="0" anchor="ctr"/>
+          <a:lstStyle/>
+          <a:p>
+            <a:pPr indent="0" marL="0">
+              <a:buNone/>
+            </a:pPr>
+            <a:r>
+              <a:rPr lang="en-US" sz="1400" dirty="0">
+                <a:solidFill>
+                  <a:srgbClr val="8BA39B"/>
+                </a:solidFill>
+                <a:latin typeface="Segoe UI" pitchFamily="34" charset="0"/>
+                <a:ea typeface="Segoe UI" pitchFamily="34" charset="-122"/>
+                <a:cs typeface="Segoe UI" pitchFamily="34" charset="-120"/>
+              </a:rPr>
+              <a:t>≤3 min · Standard approve + Strict withhold · YouTube/Loom</a:t>
+            </a:r>
+            <a:endParaRPr lang="en-US" sz="1400" dirty="0"/>
+          </a:p>
+        </p:txBody>
+      </p:sp>
+      <p:sp>
+        <p:nvSpPr>
+          <p:cNvPr id="16" name="Text 14"/>
+          <p:cNvSpPr/>
+          <p:nvPr/>
+        </p:nvSpPr>
+        <p:spPr>
+          <a:xfrm>
+            <a:off x="548640" y="6446520"/>
+            <a:ext cx="10972800" cy="274320"/>
+          </a:xfrm>
+          <a:prstGeom prst="rect">
+            <a:avLst/>
+          </a:prstGeom>
+          <a:noFill/>
+          <a:ln/>
+        </p:spPr>
+        <p:txBody>
+          <a:bodyPr wrap="square" rtlCol="0" anchor="ctr"/>
+          <a:lstStyle/>
+          <a:p>
+            <a:pPr indent="0" marL="0">
+              <a:buNone/>
+            </a:pPr>
+            <a:r>
+              <a:rPr lang="en-US" sz="900" dirty="0">
+                <a:solidFill>
+                  <a:srgbClr val="8BA39B"/>
+                </a:solidFill>
+                <a:latin typeface="Segoe UI" pitchFamily="34" charset="0"/>
+                <a:ea typeface="Segoe UI" pitchFamily="34" charset="-122"/>
+                <a:cs typeface="Segoe UI" pitchFamily="34" charset="-120"/>
+              </a:rPr>
+              <a:t>GravAI — Verified data commerce on Arc · 10</a:t>
+            </a:r>
+            <a:endParaRPr lang="en-US" sz="900" dirty="0"/>
+          </a:p>
+        </p:txBody>
+      </p:sp>
+    </p:spTree>
+  </p:cSld>
+  <p:clrMapOvr>
+    <a:masterClrMapping/>
+  </p:clrMapOvr>
+</p:sld>
+</file>
+
+<file path=ppt/slides/slide11.xml><?xml version="1.0" encoding="utf-8"?>
+<p:sld xmlns:a="http://schemas.openxmlformats.org/drawingml/2006/main" xmlns:r="http://schemas.openxmlformats.org/officeDocument/2006/relationships" xmlns:p="http://schemas.openxmlformats.org/presentationml/2006/main">
+  <p:cSld name="Slide 11">
+    <p:bg>
+      <p:bgPr>
+        <a:solidFill>
+          <a:srgbClr val="0B0F0E"/>
+        </a:solidFill>
+      </p:bgPr>
+    </p:bg>
+    <p:spTree>
+      <p:nvGrpSpPr>
+        <p:cNvPr id="1" name=""/>
+        <p:cNvGrpSpPr/>
+        <p:nvPr/>
+      </p:nvGrpSpPr>
+      <p:grpSpPr>
+        <a:xfrm>
+          <a:off x="0" y="0"/>
+          <a:ext cx="0" cy="0"/>
+          <a:chOff x="0" y="0"/>
+          <a:chExt cx="0" cy="0"/>
+        </a:xfrm>
+      </p:grpSpPr>
+      <p:sp>
+        <p:nvSpPr>
+          <p:cNvPr id="2" name="Shape 0"/>
+          <p:cNvSpPr/>
+          <p:nvPr/>
+        </p:nvSpPr>
+        <p:spPr>
+          <a:xfrm>
+            <a:off x="0" y="0"/>
+            <a:ext cx="109728" cy="6858000"/>
+          </a:xfrm>
+          <a:prstGeom prst="rect">
+            <a:avLst/>
+          </a:prstGeom>
+          <a:solidFill>
+            <a:srgbClr val="34D399"/>
+          </a:solidFill>
+          <a:ln/>
+        </p:spPr>
+      </p:sp>
+      <p:sp>
+        <p:nvSpPr>
           <p:cNvPr id="3" name="Text 1"/>
           <p:cNvSpPr/>
           <p:nvPr/>
@@ -2036,8 +2666,8 @@
         </p:nvSpPr>
         <p:spPr>
           <a:xfrm>
-            <a:off x="822960" y="5120640"/>
-            <a:ext cx="9144000" cy="731520"/>
+            <a:off x="822960" y="4937760"/>
+            <a:ext cx="10058400" cy="822960"/>
           </a:xfrm>
           <a:prstGeom prst="rect">
             <a:avLst/>
@@ -2064,7 +2694,7 @@
                 <a:ea typeface="Segoe UI" pitchFamily="34" charset="-122"/>
                 <a:cs typeface="Segoe UI" pitchFamily="34" charset="-120"/>
               </a:rPr>
-              <a:t>Matheus Procópio</a:t>
+              <a:t>Prototype fixtures + real USDC nanopayments on Arc testnet</a:t>
             </a:r>
             <a:endParaRPr lang="en-US" sz="1400" dirty="0"/>
           </a:p>
@@ -2084,7 +2714,7 @@
                 <a:ea typeface="Segoe UI" pitchFamily="34" charset="-122"/>
                 <a:cs typeface="Segoe UI" pitchFamily="34" charset="-120"/>
               </a:rPr>
-              <a:t>github.com/tetheusz/gravai · Agentic Economy Track</a:t>
+              <a:t>Matheus Procópio · github.com/tetheusz/gravai · Agentic Economy</a:t>
             </a:r>
             <a:endParaRPr lang="en-US" sz="1400" dirty="0"/>
           </a:p>

</xml_diff>